<commit_message>
narrator validator: "<issuer> <fund code>" without "Portföy" is a name too (Garanti GZP); garanti fix measured
- Paid re-measurement of the garanti fix (eval 20261029-153753-garanti-fix-measured,
  $0.088; the cached template text was archived first): validator 3/3, no template;
  the cost ledger showed the first attempt failed on "Garanti GZP"
- validator: masks the issuer without its issuer word followed by the fund code;
  "garanti" not right before the code is still a finding; tests both ways
- found-and-fixed #22; README fixes row, deliverable 5 (5.6 c, open items) and deck E8;
  tests 3,082 (151 files)

Co-Authored-By: Claude Opus 5.5 (1M context) <noreply@anthropic.com>
</commit_message>
<xml_diff>
--- a/docs/teslim/sunum/07-sunum.pptx
+++ b/docs/teslim/sunum/07-sunum.pptx
@@ -129,13 +129,13 @@
   <p:extLst>
     <p:ext uri="{521415D9-36F7-43E2-AB2F-B90AF26B5E84}">
       <p14:sectionLst xmlns:p14="http://schemas.microsoft.com/office/powerpoint/2010/main">
-        <p14:section name="Giriş" id="{4A2E5428-A46E-40EB-B989-DA3B31041646}">
+        <p14:section name="Giriş" id="{8679D8CC-7BCC-997D-0891-7020282C9FB9}">
           <p14:sldIdLst>
             <p14:sldId id="256"/>
             <p14:sldId id="257"/>
           </p14:sldIdLst>
         </p14:section>
-        <p14:section name="Çözüm" id="{12B2ACB8-1E91-36B8-54C6-C494DCCED272}">
+        <p14:section name="Çözüm" id="{668CA352-57B2-2184-E759-ADAD23962CF2}">
           <p14:sldIdLst>
             <p14:sldId id="258"/>
             <p14:sldId id="259"/>
@@ -145,19 +145,19 @@
             <p14:sldId id="263"/>
           </p14:sldIdLst>
         </p14:section>
-        <p14:section name="Demo" id="{32C1499C-E3E6-6A5D-BD2D-2D0ABA33C5F6}">
+        <p14:section name="Demo" id="{168643CC-9698-679A-8E64-F375157EAAD7}">
           <p14:sldIdLst>
             <p14:sldId id="264"/>
           </p14:sldIdLst>
         </p14:section>
-        <p14:section name="Sonuçlar" id="{A677FB6F-1487-890E-8CDC-380550958D48}">
+        <p14:section name="Sonuçlar" id="{27E9C16C-DEEA-52BD-979C-617774EBB711}">
           <p14:sldIdLst>
             <p14:sldId id="265"/>
             <p14:sldId id="266"/>
             <p14:sldId id="267"/>
           </p14:sldIdLst>
         </p14:section>
-        <p14:section name="Ek" id="{F1811340-79BE-A369-38D8-0CB8AFEE9BEF}">
+        <p14:section name="Ek" id="{B4836AC6-44F6-73B5-EDAA-4B18D70AF4E4}">
           <p14:sldIdLst>
             <p14:sldId id="268"/>
             <p14:sldId id="269"/>
@@ -206,7 +206,7 @@
     </p:spTree>
     <p:extLst>
       <p:ext uri="{BB962C8B-B14F-4D97-AF65-F5344CB8AC3E}">
-        <p14:creationId xmlns:p14="http://schemas.microsoft.com/office/powerpoint/2010/main" val="3265325785"/>
+        <p14:creationId xmlns:p14="http://schemas.microsoft.com/office/powerpoint/2010/main" val="596010215"/>
       </p:ext>
     </p:extLst>
   </p:cSld>
@@ -4129,7 +4129,7 @@
                 <a:ea typeface="Arial" pitchFamily="34" charset="-122"/>
                 <a:cs typeface="Arial" pitchFamily="34" charset="-120"/>
               </a:rPr>
-              <a:t>3.078 pytest, 458 web testi; ağ yok, sahte model</a:t>
+              <a:t>3.082 pytest, 458 web testi; ağ yok, sahte model</a:t>
             </a:r>
             <a:endParaRPr lang="en-US" sz="1250" dirty="0"/>
           </a:p>
@@ -5852,7 +5852,7 @@
                 <a:ea typeface="Arial" pitchFamily="34" charset="-122"/>
                 <a:cs typeface="Arial" pitchFamily="34" charset="-120"/>
               </a:rPr>
-              <a:t>"kurallar %100" yeterli değil. Çıktılar arası karşılaştırma ve canlı kontrol gerekir. Tüm liste: docs/found-and-fixed.md (20 kayıt).</a:t>
+              <a:t>"kurallar %100" yeterli değil. Çıktılar arası karşılaştırma ve canlı kontrol gerekir. Tüm liste: docs/found-and-fixed.md (22 kayıt).</a:t>
             </a:r>
             <a:endParaRPr lang="en-US" sz="1250" dirty="0"/>
           </a:p>
@@ -21949,7 +21949,7 @@
                           <a:ea typeface="Arial" pitchFamily="34" charset="-122"/>
                           <a:cs typeface="Arial" pitchFamily="34" charset="-120"/>
                         </a:rPr>
-                        <a:t>Tarama kurucu adını da okuyordu</a:t>
+                        <a:t>Tarama kurucu adını da okuyordu; ücretli yeniden ölçüm ikinci biçimi buldu ("Garanti GZP")</a:t>
                       </a:r>
                       <a:endParaRPr lang="en-US" sz="1200" dirty="0">
                         <a:latin typeface="Arial" charset="0"/>
@@ -22017,7 +22017,7 @@
                           <a:ea typeface="Arial" pitchFamily="34" charset="-122"/>
                           <a:cs typeface="Arial" pitchFamily="34" charset="-120"/>
                         </a:rPr>
-                        <a:t>Kurucu adı taramadan çıkarıldı; yasak ifadenin kendisi hâlâ yakalanır</a:t>
+                        <a:t>Kurucu adı ve fon kodu taramadan çıkarıldı; ölçüm 3/3; tek başına "garanti" hâlâ yakalanır</a:t>
                       </a:r>
                       <a:endParaRPr lang="en-US" sz="1200" dirty="0">
                         <a:latin typeface="Arial" charset="0"/>

</xml_diff>